<commit_message>
added_quiz app for testing
</commit_message>
<xml_diff>
--- a/PPT/Communication_ Protocols.pptx
+++ b/PPT/Communication_ Protocols.pptx
@@ -30,7 +30,7 @@
   <p:notesSz cx="6858000" cy="9144000"/>
   <p:embeddedFontLst>
     <p:embeddedFont>
-      <p:font typeface="Fira Code" panose="020B0809050000020004" pitchFamily="49" charset="0"/>
+      <p:font typeface="Fira Code" panose="020F0502020204030204" charset="0"/>
       <p:regular r:id="rId20"/>
       <p:bold r:id="rId21"/>
     </p:embeddedFont>
@@ -235,7 +235,7 @@
           <a:p>
             <a:fld id="{FAA5E78D-4A7E-4A21-A7D6-34ED7A83EC06}" type="datetimeFigureOut">
               <a:rPr lang="en-IN" smtClean="0"/>
-              <a:t>22-09-2026</a:t>
+              <a:t>24-09-2026</a:t>
             </a:fld>
             <a:endParaRPr lang="en-IN"/>
           </a:p>
@@ -1037,7 +1037,7 @@
           <a:p>
             <a:fld id="{5BCAD085-E8A6-8845-BD4E-CB4CCA059FC4}" type="datetimeFigureOut">
               <a:rPr lang="en-US" smtClean="0"/>
-              <a:t>9/21/2026</a:t>
+              <a:t>9/24/2026</a:t>
             </a:fld>
             <a:endParaRPr lang="en-US"/>
           </a:p>
@@ -1205,7 +1205,7 @@
           <a:p>
             <a:fld id="{5BCAD085-E8A6-8845-BD4E-CB4CCA059FC4}" type="datetimeFigureOut">
               <a:rPr lang="en-US" smtClean="0"/>
-              <a:t>9/21/2026</a:t>
+              <a:t>9/24/2026</a:t>
             </a:fld>
             <a:endParaRPr lang="en-US"/>
           </a:p>
@@ -1383,7 +1383,7 @@
           <a:p>
             <a:fld id="{5BCAD085-E8A6-8845-BD4E-CB4CCA059FC4}" type="datetimeFigureOut">
               <a:rPr lang="en-US" smtClean="0"/>
-              <a:t>9/21/2026</a:t>
+              <a:t>9/24/2026</a:t>
             </a:fld>
             <a:endParaRPr lang="en-US"/>
           </a:p>
@@ -2171,7 +2171,7 @@
           <a:p>
             <a:fld id="{5BCAD085-E8A6-8845-BD4E-CB4CCA059FC4}" type="datetimeFigureOut">
               <a:rPr lang="en-US" smtClean="0"/>
-              <a:t>9/21/2026</a:t>
+              <a:t>9/24/2026</a:t>
             </a:fld>
             <a:endParaRPr lang="en-US"/>
           </a:p>
@@ -2416,7 +2416,7 @@
           <a:p>
             <a:fld id="{5BCAD085-E8A6-8845-BD4E-CB4CCA059FC4}" type="datetimeFigureOut">
               <a:rPr lang="en-US" smtClean="0"/>
-              <a:t>9/21/2026</a:t>
+              <a:t>9/24/2026</a:t>
             </a:fld>
             <a:endParaRPr lang="en-US"/>
           </a:p>
@@ -2701,7 +2701,7 @@
           <a:p>
             <a:fld id="{5BCAD085-E8A6-8845-BD4E-CB4CCA059FC4}" type="datetimeFigureOut">
               <a:rPr lang="en-US" smtClean="0"/>
-              <a:t>9/21/2026</a:t>
+              <a:t>9/24/2026</a:t>
             </a:fld>
             <a:endParaRPr lang="en-US"/>
           </a:p>
@@ -3120,7 +3120,7 @@
           <a:p>
             <a:fld id="{5BCAD085-E8A6-8845-BD4E-CB4CCA059FC4}" type="datetimeFigureOut">
               <a:rPr lang="en-US" smtClean="0"/>
-              <a:t>9/21/2026</a:t>
+              <a:t>9/24/2026</a:t>
             </a:fld>
             <a:endParaRPr lang="en-US"/>
           </a:p>
@@ -3237,7 +3237,7 @@
           <a:p>
             <a:fld id="{5BCAD085-E8A6-8845-BD4E-CB4CCA059FC4}" type="datetimeFigureOut">
               <a:rPr lang="en-US" smtClean="0"/>
-              <a:t>9/21/2026</a:t>
+              <a:t>9/24/2026</a:t>
             </a:fld>
             <a:endParaRPr lang="en-US"/>
           </a:p>
@@ -3332,7 +3332,7 @@
           <a:p>
             <a:fld id="{5BCAD085-E8A6-8845-BD4E-CB4CCA059FC4}" type="datetimeFigureOut">
               <a:rPr lang="en-US" smtClean="0"/>
-              <a:t>9/21/2026</a:t>
+              <a:t>9/24/2026</a:t>
             </a:fld>
             <a:endParaRPr lang="en-US"/>
           </a:p>
@@ -3607,7 +3607,7 @@
           <a:p>
             <a:fld id="{5BCAD085-E8A6-8845-BD4E-CB4CCA059FC4}" type="datetimeFigureOut">
               <a:rPr lang="en-US" smtClean="0"/>
-              <a:t>9/21/2026</a:t>
+              <a:t>9/24/2026</a:t>
             </a:fld>
             <a:endParaRPr lang="en-US"/>
           </a:p>
@@ -3859,7 +3859,7 @@
           <a:p>
             <a:fld id="{5BCAD085-E8A6-8845-BD4E-CB4CCA059FC4}" type="datetimeFigureOut">
               <a:rPr lang="en-US" smtClean="0"/>
-              <a:t>9/21/2026</a:t>
+              <a:t>9/24/2026</a:t>
             </a:fld>
             <a:endParaRPr lang="en-US"/>
           </a:p>
@@ -4070,7 +4070,7 @@
           <a:p>
             <a:fld id="{5BCAD085-E8A6-8845-BD4E-CB4CCA059FC4}" type="datetimeFigureOut">
               <a:rPr lang="en-US" smtClean="0"/>
-              <a:t>9/21/2026</a:t>
+              <a:t>9/24/2026</a:t>
             </a:fld>
             <a:endParaRPr lang="en-US"/>
           </a:p>
@@ -14558,21 +14558,21 @@
           <p:nvPr>
             <p:extLst>
               <p:ext uri="{D42A27DB-BD31-4B8C-83A1-F6EECF244321}">
-                <p14:modId xmlns:p14="http://schemas.microsoft.com/office/powerpoint/2010/main" val="871744515"/>
+                <p14:modId xmlns:p14="http://schemas.microsoft.com/office/powerpoint/2010/main" val="4048879903"/>
               </p:ext>
             </p:extLst>
           </p:nvPr>
         </p:nvGraphicFramePr>
         <p:xfrm>
-          <a:off x="1566042" y="1177159"/>
-          <a:ext cx="9075682" cy="5223640"/>
+          <a:off x="1453896" y="1177159"/>
+          <a:ext cx="9187828" cy="5223640"/>
         </p:xfrm>
         <a:graphic>
           <a:graphicData uri="http://schemas.openxmlformats.org/drawingml/2006/table">
             <a:tbl>
               <a:tblPr/>
               <a:tblGrid>
-                <a:gridCol w="1166648">
+                <a:gridCol w="1278794">
                   <a:extLst>
                     <a:ext uri="{9D8B030D-6E8A-4147-A177-3AD203B41FA5}">
                       <a16:colId xmlns:a16="http://schemas.microsoft.com/office/drawing/2014/main" val="20000"/>
@@ -14618,17 +14618,41 @@
                     </a:p>
                   </a:txBody>
                   <a:tcPr anchor="ctr">
-                    <a:lnL>
-                      <a:noFill/>
+                    <a:lnL w="12700" cap="flat" cmpd="sng" algn="ctr">
+                      <a:solidFill>
+                        <a:schemeClr val="tx1"/>
+                      </a:solidFill>
+                      <a:prstDash val="solid"/>
+                      <a:round/>
+                      <a:headEnd type="none" w="med" len="med"/>
+                      <a:tailEnd type="none" w="med" len="med"/>
                     </a:lnL>
-                    <a:lnR>
-                      <a:noFill/>
+                    <a:lnR w="12700" cap="flat" cmpd="sng" algn="ctr">
+                      <a:solidFill>
+                        <a:schemeClr val="tx1"/>
+                      </a:solidFill>
+                      <a:prstDash val="solid"/>
+                      <a:round/>
+                      <a:headEnd type="none" w="med" len="med"/>
+                      <a:tailEnd type="none" w="med" len="med"/>
                     </a:lnR>
-                    <a:lnT>
-                      <a:noFill/>
+                    <a:lnT w="12700" cap="flat" cmpd="sng" algn="ctr">
+                      <a:solidFill>
+                        <a:schemeClr val="tx1"/>
+                      </a:solidFill>
+                      <a:prstDash val="solid"/>
+                      <a:round/>
+                      <a:headEnd type="none" w="med" len="med"/>
+                      <a:tailEnd type="none" w="med" len="med"/>
                     </a:lnT>
-                    <a:lnB>
-                      <a:noFill/>
+                    <a:lnB w="12700" cap="flat" cmpd="sng" algn="ctr">
+                      <a:solidFill>
+                        <a:schemeClr val="tx1"/>
+                      </a:solidFill>
+                      <a:prstDash val="solid"/>
+                      <a:round/>
+                      <a:headEnd type="none" w="med" len="med"/>
+                      <a:tailEnd type="none" w="med" len="med"/>
                     </a:lnB>
                     <a:solidFill>
                       <a:schemeClr val="tx2"/>
@@ -14651,17 +14675,41 @@
                     </a:p>
                   </a:txBody>
                   <a:tcPr anchor="ctr">
-                    <a:lnL>
-                      <a:noFill/>
+                    <a:lnL w="12700" cap="flat" cmpd="sng" algn="ctr">
+                      <a:solidFill>
+                        <a:schemeClr val="tx1"/>
+                      </a:solidFill>
+                      <a:prstDash val="solid"/>
+                      <a:round/>
+                      <a:headEnd type="none" w="med" len="med"/>
+                      <a:tailEnd type="none" w="med" len="med"/>
                     </a:lnL>
-                    <a:lnR>
-                      <a:noFill/>
+                    <a:lnR w="12700" cap="flat" cmpd="sng" algn="ctr">
+                      <a:solidFill>
+                        <a:schemeClr val="tx1"/>
+                      </a:solidFill>
+                      <a:prstDash val="solid"/>
+                      <a:round/>
+                      <a:headEnd type="none" w="med" len="med"/>
+                      <a:tailEnd type="none" w="med" len="med"/>
                     </a:lnR>
-                    <a:lnT>
-                      <a:noFill/>
+                    <a:lnT w="12700" cap="flat" cmpd="sng" algn="ctr">
+                      <a:solidFill>
+                        <a:schemeClr val="tx1"/>
+                      </a:solidFill>
+                      <a:prstDash val="solid"/>
+                      <a:round/>
+                      <a:headEnd type="none" w="med" len="med"/>
+                      <a:tailEnd type="none" w="med" len="med"/>
                     </a:lnT>
-                    <a:lnB>
-                      <a:noFill/>
+                    <a:lnB w="12700" cap="flat" cmpd="sng" algn="ctr">
+                      <a:solidFill>
+                        <a:schemeClr val="tx1"/>
+                      </a:solidFill>
+                      <a:prstDash val="solid"/>
+                      <a:round/>
+                      <a:headEnd type="none" w="med" len="med"/>
+                      <a:tailEnd type="none" w="med" len="med"/>
                     </a:lnB>
                     <a:solidFill>
                       <a:schemeClr val="tx2"/>
@@ -14684,17 +14732,41 @@
                     </a:p>
                   </a:txBody>
                   <a:tcPr anchor="ctr">
-                    <a:lnL>
-                      <a:noFill/>
+                    <a:lnL w="12700" cap="flat" cmpd="sng" algn="ctr">
+                      <a:solidFill>
+                        <a:schemeClr val="tx1"/>
+                      </a:solidFill>
+                      <a:prstDash val="solid"/>
+                      <a:round/>
+                      <a:headEnd type="none" w="med" len="med"/>
+                      <a:tailEnd type="none" w="med" len="med"/>
                     </a:lnL>
-                    <a:lnR>
-                      <a:noFill/>
+                    <a:lnR w="12700" cap="flat" cmpd="sng" algn="ctr">
+                      <a:solidFill>
+                        <a:schemeClr val="tx1"/>
+                      </a:solidFill>
+                      <a:prstDash val="solid"/>
+                      <a:round/>
+                      <a:headEnd type="none" w="med" len="med"/>
+                      <a:tailEnd type="none" w="med" len="med"/>
                     </a:lnR>
-                    <a:lnT>
-                      <a:noFill/>
+                    <a:lnT w="12700" cap="flat" cmpd="sng" algn="ctr">
+                      <a:solidFill>
+                        <a:schemeClr val="tx1"/>
+                      </a:solidFill>
+                      <a:prstDash val="solid"/>
+                      <a:round/>
+                      <a:headEnd type="none" w="med" len="med"/>
+                      <a:tailEnd type="none" w="med" len="med"/>
                     </a:lnT>
-                    <a:lnB>
-                      <a:noFill/>
+                    <a:lnB w="12700" cap="flat" cmpd="sng" algn="ctr">
+                      <a:solidFill>
+                        <a:schemeClr val="tx1"/>
+                      </a:solidFill>
+                      <a:prstDash val="solid"/>
+                      <a:round/>
+                      <a:headEnd type="none" w="med" len="med"/>
+                      <a:tailEnd type="none" w="med" len="med"/>
                     </a:lnB>
                     <a:solidFill>
                       <a:schemeClr val="tx2"/>
@@ -14717,17 +14789,41 @@
                     </a:p>
                   </a:txBody>
                   <a:tcPr anchor="ctr">
-                    <a:lnL>
-                      <a:noFill/>
+                    <a:lnL w="12700" cap="flat" cmpd="sng" algn="ctr">
+                      <a:solidFill>
+                        <a:schemeClr val="tx1"/>
+                      </a:solidFill>
+                      <a:prstDash val="solid"/>
+                      <a:round/>
+                      <a:headEnd type="none" w="med" len="med"/>
+                      <a:tailEnd type="none" w="med" len="med"/>
                     </a:lnL>
-                    <a:lnR>
-                      <a:noFill/>
+                    <a:lnR w="12700" cap="flat" cmpd="sng" algn="ctr">
+                      <a:solidFill>
+                        <a:schemeClr val="tx1"/>
+                      </a:solidFill>
+                      <a:prstDash val="solid"/>
+                      <a:round/>
+                      <a:headEnd type="none" w="med" len="med"/>
+                      <a:tailEnd type="none" w="med" len="med"/>
                     </a:lnR>
-                    <a:lnT>
-                      <a:noFill/>
+                    <a:lnT w="12700" cap="flat" cmpd="sng" algn="ctr">
+                      <a:solidFill>
+                        <a:schemeClr val="tx1"/>
+                      </a:solidFill>
+                      <a:prstDash val="solid"/>
+                      <a:round/>
+                      <a:headEnd type="none" w="med" len="med"/>
+                      <a:tailEnd type="none" w="med" len="med"/>
                     </a:lnT>
-                    <a:lnB>
-                      <a:noFill/>
+                    <a:lnB w="12700" cap="flat" cmpd="sng" algn="ctr">
+                      <a:solidFill>
+                        <a:schemeClr val="tx1"/>
+                      </a:solidFill>
+                      <a:prstDash val="solid"/>
+                      <a:round/>
+                      <a:headEnd type="none" w="med" len="med"/>
+                      <a:tailEnd type="none" w="med" len="med"/>
                     </a:lnB>
                     <a:solidFill>
                       <a:schemeClr val="tx2"/>
@@ -14750,24 +14846,48 @@
                         <a:buNone/>
                       </a:pPr>
                       <a:r>
-                        <a:rPr lang="en-IN" b="1"/>
+                        <a:rPr lang="en-IN" b="1" dirty="0"/>
                         <a:t>Type</a:t>
                       </a:r>
-                      <a:endParaRPr lang="en-IN"/>
+                      <a:endParaRPr lang="en-IN" dirty="0"/>
                     </a:p>
                   </a:txBody>
                   <a:tcPr anchor="ctr">
-                    <a:lnL>
-                      <a:noFill/>
+                    <a:lnL w="12700" cap="flat" cmpd="sng" algn="ctr">
+                      <a:solidFill>
+                        <a:schemeClr val="tx1"/>
+                      </a:solidFill>
+                      <a:prstDash val="solid"/>
+                      <a:round/>
+                      <a:headEnd type="none" w="med" len="med"/>
+                      <a:tailEnd type="none" w="med" len="med"/>
                     </a:lnL>
-                    <a:lnR>
-                      <a:noFill/>
+                    <a:lnR w="12700" cap="flat" cmpd="sng" algn="ctr">
+                      <a:solidFill>
+                        <a:schemeClr val="tx1"/>
+                      </a:solidFill>
+                      <a:prstDash val="solid"/>
+                      <a:round/>
+                      <a:headEnd type="none" w="med" len="med"/>
+                      <a:tailEnd type="none" w="med" len="med"/>
                     </a:lnR>
-                    <a:lnT>
-                      <a:noFill/>
+                    <a:lnT w="12700" cap="flat" cmpd="sng" algn="ctr">
+                      <a:solidFill>
+                        <a:schemeClr val="tx1"/>
+                      </a:solidFill>
+                      <a:prstDash val="solid"/>
+                      <a:round/>
+                      <a:headEnd type="none" w="med" len="med"/>
+                      <a:tailEnd type="none" w="med" len="med"/>
                     </a:lnT>
-                    <a:lnB>
-                      <a:noFill/>
+                    <a:lnB w="12700" cap="flat" cmpd="sng" algn="ctr">
+                      <a:solidFill>
+                        <a:schemeClr val="tx1"/>
+                      </a:solidFill>
+                      <a:prstDash val="solid"/>
+                      <a:round/>
+                      <a:headEnd type="none" w="med" len="med"/>
+                      <a:tailEnd type="none" w="med" len="med"/>
                     </a:lnB>
                     <a:solidFill>
                       <a:srgbClr val="FFFFFF"/>
@@ -14789,17 +14909,41 @@
                     </a:p>
                   </a:txBody>
                   <a:tcPr anchor="ctr">
-                    <a:lnL>
-                      <a:noFill/>
+                    <a:lnL w="12700" cap="flat" cmpd="sng" algn="ctr">
+                      <a:solidFill>
+                        <a:schemeClr val="tx1"/>
+                      </a:solidFill>
+                      <a:prstDash val="solid"/>
+                      <a:round/>
+                      <a:headEnd type="none" w="med" len="med"/>
+                      <a:tailEnd type="none" w="med" len="med"/>
                     </a:lnL>
-                    <a:lnR>
-                      <a:noFill/>
+                    <a:lnR w="12700" cap="flat" cmpd="sng" algn="ctr">
+                      <a:solidFill>
+                        <a:schemeClr val="tx1"/>
+                      </a:solidFill>
+                      <a:prstDash val="solid"/>
+                      <a:round/>
+                      <a:headEnd type="none" w="med" len="med"/>
+                      <a:tailEnd type="none" w="med" len="med"/>
                     </a:lnR>
-                    <a:lnT>
-                      <a:noFill/>
+                    <a:lnT w="12700" cap="flat" cmpd="sng" algn="ctr">
+                      <a:solidFill>
+                        <a:schemeClr val="tx1"/>
+                      </a:solidFill>
+                      <a:prstDash val="solid"/>
+                      <a:round/>
+                      <a:headEnd type="none" w="med" len="med"/>
+                      <a:tailEnd type="none" w="med" len="med"/>
                     </a:lnT>
-                    <a:lnB>
-                      <a:noFill/>
+                    <a:lnB w="12700" cap="flat" cmpd="sng" algn="ctr">
+                      <a:solidFill>
+                        <a:schemeClr val="tx1"/>
+                      </a:solidFill>
+                      <a:prstDash val="solid"/>
+                      <a:round/>
+                      <a:headEnd type="none" w="med" len="med"/>
+                      <a:tailEnd type="none" w="med" len="med"/>
                     </a:lnB>
                     <a:solidFill>
                       <a:srgbClr val="FFFFFF"/>
@@ -14821,17 +14965,41 @@
                     </a:p>
                   </a:txBody>
                   <a:tcPr anchor="ctr">
-                    <a:lnL>
-                      <a:noFill/>
+                    <a:lnL w="12700" cap="flat" cmpd="sng" algn="ctr">
+                      <a:solidFill>
+                        <a:schemeClr val="tx1"/>
+                      </a:solidFill>
+                      <a:prstDash val="solid"/>
+                      <a:round/>
+                      <a:headEnd type="none" w="med" len="med"/>
+                      <a:tailEnd type="none" w="med" len="med"/>
                     </a:lnL>
-                    <a:lnR>
-                      <a:noFill/>
+                    <a:lnR w="12700" cap="flat" cmpd="sng" algn="ctr">
+                      <a:solidFill>
+                        <a:schemeClr val="tx1"/>
+                      </a:solidFill>
+                      <a:prstDash val="solid"/>
+                      <a:round/>
+                      <a:headEnd type="none" w="med" len="med"/>
+                      <a:tailEnd type="none" w="med" len="med"/>
                     </a:lnR>
-                    <a:lnT>
-                      <a:noFill/>
+                    <a:lnT w="12700" cap="flat" cmpd="sng" algn="ctr">
+                      <a:solidFill>
+                        <a:schemeClr val="tx1"/>
+                      </a:solidFill>
+                      <a:prstDash val="solid"/>
+                      <a:round/>
+                      <a:headEnd type="none" w="med" len="med"/>
+                      <a:tailEnd type="none" w="med" len="med"/>
                     </a:lnT>
-                    <a:lnB>
-                      <a:noFill/>
+                    <a:lnB w="12700" cap="flat" cmpd="sng" algn="ctr">
+                      <a:solidFill>
+                        <a:schemeClr val="tx1"/>
+                      </a:solidFill>
+                      <a:prstDash val="solid"/>
+                      <a:round/>
+                      <a:headEnd type="none" w="med" len="med"/>
+                      <a:tailEnd type="none" w="med" len="med"/>
                     </a:lnB>
                     <a:solidFill>
                       <a:srgbClr val="FFFFFF"/>
@@ -14853,17 +15021,41 @@
                     </a:p>
                   </a:txBody>
                   <a:tcPr anchor="ctr">
-                    <a:lnL>
-                      <a:noFill/>
+                    <a:lnL w="12700" cap="flat" cmpd="sng" algn="ctr">
+                      <a:solidFill>
+                        <a:schemeClr val="tx1"/>
+                      </a:solidFill>
+                      <a:prstDash val="solid"/>
+                      <a:round/>
+                      <a:headEnd type="none" w="med" len="med"/>
+                      <a:tailEnd type="none" w="med" len="med"/>
                     </a:lnL>
-                    <a:lnR>
-                      <a:noFill/>
+                    <a:lnR w="12700" cap="flat" cmpd="sng" algn="ctr">
+                      <a:solidFill>
+                        <a:schemeClr val="tx1"/>
+                      </a:solidFill>
+                      <a:prstDash val="solid"/>
+                      <a:round/>
+                      <a:headEnd type="none" w="med" len="med"/>
+                      <a:tailEnd type="none" w="med" len="med"/>
                     </a:lnR>
-                    <a:lnT>
-                      <a:noFill/>
+                    <a:lnT w="12700" cap="flat" cmpd="sng" algn="ctr">
+                      <a:solidFill>
+                        <a:schemeClr val="tx1"/>
+                      </a:solidFill>
+                      <a:prstDash val="solid"/>
+                      <a:round/>
+                      <a:headEnd type="none" w="med" len="med"/>
+                      <a:tailEnd type="none" w="med" len="med"/>
                     </a:lnT>
-                    <a:lnB>
-                      <a:noFill/>
+                    <a:lnB w="12700" cap="flat" cmpd="sng" algn="ctr">
+                      <a:solidFill>
+                        <a:schemeClr val="tx1"/>
+                      </a:solidFill>
+                      <a:prstDash val="solid"/>
+                      <a:round/>
+                      <a:headEnd type="none" w="med" len="med"/>
+                      <a:tailEnd type="none" w="med" len="med"/>
                     </a:lnB>
                     <a:solidFill>
                       <a:srgbClr val="FFFFFF"/>
@@ -14893,17 +15085,41 @@
                     </a:p>
                   </a:txBody>
                   <a:tcPr anchor="ctr">
-                    <a:lnL>
-                      <a:noFill/>
+                    <a:lnL w="12700" cap="flat" cmpd="sng" algn="ctr">
+                      <a:solidFill>
+                        <a:schemeClr val="tx1"/>
+                      </a:solidFill>
+                      <a:prstDash val="solid"/>
+                      <a:round/>
+                      <a:headEnd type="none" w="med" len="med"/>
+                      <a:tailEnd type="none" w="med" len="med"/>
                     </a:lnL>
-                    <a:lnR>
-                      <a:noFill/>
+                    <a:lnR w="12700" cap="flat" cmpd="sng" algn="ctr">
+                      <a:solidFill>
+                        <a:schemeClr val="tx1"/>
+                      </a:solidFill>
+                      <a:prstDash val="solid"/>
+                      <a:round/>
+                      <a:headEnd type="none" w="med" len="med"/>
+                      <a:tailEnd type="none" w="med" len="med"/>
                     </a:lnR>
-                    <a:lnT>
-                      <a:noFill/>
+                    <a:lnT w="12700" cap="flat" cmpd="sng" algn="ctr">
+                      <a:solidFill>
+                        <a:schemeClr val="tx1"/>
+                      </a:solidFill>
+                      <a:prstDash val="solid"/>
+                      <a:round/>
+                      <a:headEnd type="none" w="med" len="med"/>
+                      <a:tailEnd type="none" w="med" len="med"/>
                     </a:lnT>
-                    <a:lnB>
-                      <a:noFill/>
+                    <a:lnB w="12700" cap="flat" cmpd="sng" algn="ctr">
+                      <a:solidFill>
+                        <a:schemeClr val="tx1"/>
+                      </a:solidFill>
+                      <a:prstDash val="solid"/>
+                      <a:round/>
+                      <a:headEnd type="none" w="med" len="med"/>
+                      <a:tailEnd type="none" w="med" len="med"/>
                     </a:lnB>
                     <a:solidFill>
                       <a:srgbClr val="F8FAFC"/>
@@ -14919,23 +15135,47 @@
                         <a:buNone/>
                       </a:pPr>
                       <a:r>
-                        <a:rPr lang="en-IN"/>
+                        <a:rPr lang="en-IN" dirty="0"/>
                         <a:t>2: TX, RX</a:t>
                       </a:r>
                     </a:p>
                   </a:txBody>
                   <a:tcPr anchor="ctr">
-                    <a:lnL>
-                      <a:noFill/>
+                    <a:lnL w="12700" cap="flat" cmpd="sng" algn="ctr">
+                      <a:solidFill>
+                        <a:schemeClr val="tx1"/>
+                      </a:solidFill>
+                      <a:prstDash val="solid"/>
+                      <a:round/>
+                      <a:headEnd type="none" w="med" len="med"/>
+                      <a:tailEnd type="none" w="med" len="med"/>
                     </a:lnL>
-                    <a:lnR>
-                      <a:noFill/>
+                    <a:lnR w="12700" cap="flat" cmpd="sng" algn="ctr">
+                      <a:solidFill>
+                        <a:schemeClr val="tx1"/>
+                      </a:solidFill>
+                      <a:prstDash val="solid"/>
+                      <a:round/>
+                      <a:headEnd type="none" w="med" len="med"/>
+                      <a:tailEnd type="none" w="med" len="med"/>
                     </a:lnR>
-                    <a:lnT>
-                      <a:noFill/>
+                    <a:lnT w="12700" cap="flat" cmpd="sng" algn="ctr">
+                      <a:solidFill>
+                        <a:schemeClr val="tx1"/>
+                      </a:solidFill>
+                      <a:prstDash val="solid"/>
+                      <a:round/>
+                      <a:headEnd type="none" w="med" len="med"/>
+                      <a:tailEnd type="none" w="med" len="med"/>
                     </a:lnT>
-                    <a:lnB>
-                      <a:noFill/>
+                    <a:lnB w="12700" cap="flat" cmpd="sng" algn="ctr">
+                      <a:solidFill>
+                        <a:schemeClr val="tx1"/>
+                      </a:solidFill>
+                      <a:prstDash val="solid"/>
+                      <a:round/>
+                      <a:headEnd type="none" w="med" len="med"/>
+                      <a:tailEnd type="none" w="med" len="med"/>
                     </a:lnB>
                     <a:solidFill>
                       <a:srgbClr val="F8FAFC"/>
@@ -14951,23 +15191,47 @@
                         <a:buNone/>
                       </a:pPr>
                       <a:r>
-                        <a:rPr lang="en-IN"/>
+                        <a:rPr lang="en-IN" dirty="0"/>
                         <a:t>2: SDA, SCL</a:t>
                       </a:r>
                     </a:p>
                   </a:txBody>
                   <a:tcPr anchor="ctr">
-                    <a:lnL>
-                      <a:noFill/>
+                    <a:lnL w="12700" cap="flat" cmpd="sng" algn="ctr">
+                      <a:solidFill>
+                        <a:schemeClr val="tx1"/>
+                      </a:solidFill>
+                      <a:prstDash val="solid"/>
+                      <a:round/>
+                      <a:headEnd type="none" w="med" len="med"/>
+                      <a:tailEnd type="none" w="med" len="med"/>
                     </a:lnL>
-                    <a:lnR>
-                      <a:noFill/>
+                    <a:lnR w="12700" cap="flat" cmpd="sng" algn="ctr">
+                      <a:solidFill>
+                        <a:schemeClr val="tx1"/>
+                      </a:solidFill>
+                      <a:prstDash val="solid"/>
+                      <a:round/>
+                      <a:headEnd type="none" w="med" len="med"/>
+                      <a:tailEnd type="none" w="med" len="med"/>
                     </a:lnR>
-                    <a:lnT>
-                      <a:noFill/>
+                    <a:lnT w="12700" cap="flat" cmpd="sng" algn="ctr">
+                      <a:solidFill>
+                        <a:schemeClr val="tx1"/>
+                      </a:solidFill>
+                      <a:prstDash val="solid"/>
+                      <a:round/>
+                      <a:headEnd type="none" w="med" len="med"/>
+                      <a:tailEnd type="none" w="med" len="med"/>
                     </a:lnT>
-                    <a:lnB>
-                      <a:noFill/>
+                    <a:lnB w="12700" cap="flat" cmpd="sng" algn="ctr">
+                      <a:solidFill>
+                        <a:schemeClr val="tx1"/>
+                      </a:solidFill>
+                      <a:prstDash val="solid"/>
+                      <a:round/>
+                      <a:headEnd type="none" w="med" len="med"/>
+                      <a:tailEnd type="none" w="med" len="med"/>
                     </a:lnB>
                     <a:solidFill>
                       <a:srgbClr val="F8FAFC"/>
@@ -14989,17 +15253,41 @@
                     </a:p>
                   </a:txBody>
                   <a:tcPr anchor="ctr">
-                    <a:lnL>
-                      <a:noFill/>
+                    <a:lnL w="12700" cap="flat" cmpd="sng" algn="ctr">
+                      <a:solidFill>
+                        <a:schemeClr val="tx1"/>
+                      </a:solidFill>
+                      <a:prstDash val="solid"/>
+                      <a:round/>
+                      <a:headEnd type="none" w="med" len="med"/>
+                      <a:tailEnd type="none" w="med" len="med"/>
                     </a:lnL>
-                    <a:lnR>
-                      <a:noFill/>
+                    <a:lnR w="12700" cap="flat" cmpd="sng" algn="ctr">
+                      <a:solidFill>
+                        <a:schemeClr val="tx1"/>
+                      </a:solidFill>
+                      <a:prstDash val="solid"/>
+                      <a:round/>
+                      <a:headEnd type="none" w="med" len="med"/>
+                      <a:tailEnd type="none" w="med" len="med"/>
                     </a:lnR>
-                    <a:lnT>
-                      <a:noFill/>
+                    <a:lnT w="12700" cap="flat" cmpd="sng" algn="ctr">
+                      <a:solidFill>
+                        <a:schemeClr val="tx1"/>
+                      </a:solidFill>
+                      <a:prstDash val="solid"/>
+                      <a:round/>
+                      <a:headEnd type="none" w="med" len="med"/>
+                      <a:tailEnd type="none" w="med" len="med"/>
                     </a:lnT>
-                    <a:lnB>
-                      <a:noFill/>
+                    <a:lnB w="12700" cap="flat" cmpd="sng" algn="ctr">
+                      <a:solidFill>
+                        <a:schemeClr val="tx1"/>
+                      </a:solidFill>
+                      <a:prstDash val="solid"/>
+                      <a:round/>
+                      <a:headEnd type="none" w="med" len="med"/>
+                      <a:tailEnd type="none" w="med" len="med"/>
                     </a:lnB>
                     <a:solidFill>
                       <a:srgbClr val="F8FAFC"/>
@@ -15032,17 +15320,41 @@
                     </a:p>
                   </a:txBody>
                   <a:tcPr anchor="ctr">
-                    <a:lnL>
-                      <a:noFill/>
+                    <a:lnL w="12700" cap="flat" cmpd="sng" algn="ctr">
+                      <a:solidFill>
+                        <a:schemeClr val="tx1"/>
+                      </a:solidFill>
+                      <a:prstDash val="solid"/>
+                      <a:round/>
+                      <a:headEnd type="none" w="med" len="med"/>
+                      <a:tailEnd type="none" w="med" len="med"/>
                     </a:lnL>
-                    <a:lnR>
-                      <a:noFill/>
+                    <a:lnR w="12700" cap="flat" cmpd="sng" algn="ctr">
+                      <a:solidFill>
+                        <a:schemeClr val="tx1"/>
+                      </a:solidFill>
+                      <a:prstDash val="solid"/>
+                      <a:round/>
+                      <a:headEnd type="none" w="med" len="med"/>
+                      <a:tailEnd type="none" w="med" len="med"/>
                     </a:lnR>
-                    <a:lnT>
-                      <a:noFill/>
+                    <a:lnT w="12700" cap="flat" cmpd="sng" algn="ctr">
+                      <a:solidFill>
+                        <a:schemeClr val="tx1"/>
+                      </a:solidFill>
+                      <a:prstDash val="solid"/>
+                      <a:round/>
+                      <a:headEnd type="none" w="med" len="med"/>
+                      <a:tailEnd type="none" w="med" len="med"/>
                     </a:lnT>
-                    <a:lnB>
-                      <a:noFill/>
+                    <a:lnB w="12700" cap="flat" cmpd="sng" algn="ctr">
+                      <a:solidFill>
+                        <a:schemeClr val="tx1"/>
+                      </a:solidFill>
+                      <a:prstDash val="solid"/>
+                      <a:round/>
+                      <a:headEnd type="none" w="med" len="med"/>
+                      <a:tailEnd type="none" w="med" len="med"/>
                     </a:lnB>
                     <a:solidFill>
                       <a:srgbClr val="FFFFFF"/>
@@ -15064,17 +15376,41 @@
                     </a:p>
                   </a:txBody>
                   <a:tcPr anchor="ctr">
-                    <a:lnL>
-                      <a:noFill/>
+                    <a:lnL w="12700" cap="flat" cmpd="sng" algn="ctr">
+                      <a:solidFill>
+                        <a:schemeClr val="tx1"/>
+                      </a:solidFill>
+                      <a:prstDash val="solid"/>
+                      <a:round/>
+                      <a:headEnd type="none" w="med" len="med"/>
+                      <a:tailEnd type="none" w="med" len="med"/>
                     </a:lnL>
-                    <a:lnR>
-                      <a:noFill/>
+                    <a:lnR w="12700" cap="flat" cmpd="sng" algn="ctr">
+                      <a:solidFill>
+                        <a:schemeClr val="tx1"/>
+                      </a:solidFill>
+                      <a:prstDash val="solid"/>
+                      <a:round/>
+                      <a:headEnd type="none" w="med" len="med"/>
+                      <a:tailEnd type="none" w="med" len="med"/>
                     </a:lnR>
-                    <a:lnT>
-                      <a:noFill/>
+                    <a:lnT w="12700" cap="flat" cmpd="sng" algn="ctr">
+                      <a:solidFill>
+                        <a:schemeClr val="tx1"/>
+                      </a:solidFill>
+                      <a:prstDash val="solid"/>
+                      <a:round/>
+                      <a:headEnd type="none" w="med" len="med"/>
+                      <a:tailEnd type="none" w="med" len="med"/>
                     </a:lnT>
-                    <a:lnB>
-                      <a:noFill/>
+                    <a:lnB w="12700" cap="flat" cmpd="sng" algn="ctr">
+                      <a:solidFill>
+                        <a:schemeClr val="tx1"/>
+                      </a:solidFill>
+                      <a:prstDash val="solid"/>
+                      <a:round/>
+                      <a:headEnd type="none" w="med" len="med"/>
+                      <a:tailEnd type="none" w="med" len="med"/>
                     </a:lnB>
                     <a:solidFill>
                       <a:srgbClr val="FFFFFF"/>
@@ -15090,23 +15426,47 @@
                         <a:buNone/>
                       </a:pPr>
                       <a:r>
-                        <a:rPr lang="en-IN"/>
+                        <a:rPr lang="en-IN" dirty="0"/>
                         <a:t>~1 Mbps</a:t>
                       </a:r>
                     </a:p>
                   </a:txBody>
                   <a:tcPr anchor="ctr">
-                    <a:lnL>
-                      <a:noFill/>
+                    <a:lnL w="12700" cap="flat" cmpd="sng" algn="ctr">
+                      <a:solidFill>
+                        <a:schemeClr val="tx1"/>
+                      </a:solidFill>
+                      <a:prstDash val="solid"/>
+                      <a:round/>
+                      <a:headEnd type="none" w="med" len="med"/>
+                      <a:tailEnd type="none" w="med" len="med"/>
                     </a:lnL>
-                    <a:lnR>
-                      <a:noFill/>
+                    <a:lnR w="12700" cap="flat" cmpd="sng" algn="ctr">
+                      <a:solidFill>
+                        <a:schemeClr val="tx1"/>
+                      </a:solidFill>
+                      <a:prstDash val="solid"/>
+                      <a:round/>
+                      <a:headEnd type="none" w="med" len="med"/>
+                      <a:tailEnd type="none" w="med" len="med"/>
                     </a:lnR>
-                    <a:lnT>
-                      <a:noFill/>
+                    <a:lnT w="12700" cap="flat" cmpd="sng" algn="ctr">
+                      <a:solidFill>
+                        <a:schemeClr val="tx1"/>
+                      </a:solidFill>
+                      <a:prstDash val="solid"/>
+                      <a:round/>
+                      <a:headEnd type="none" w="med" len="med"/>
+                      <a:tailEnd type="none" w="med" len="med"/>
                     </a:lnT>
-                    <a:lnB>
-                      <a:noFill/>
+                    <a:lnB w="12700" cap="flat" cmpd="sng" algn="ctr">
+                      <a:solidFill>
+                        <a:schemeClr val="tx1"/>
+                      </a:solidFill>
+                      <a:prstDash val="solid"/>
+                      <a:round/>
+                      <a:headEnd type="none" w="med" len="med"/>
+                      <a:tailEnd type="none" w="med" len="med"/>
                     </a:lnB>
                     <a:solidFill>
                       <a:srgbClr val="FFFFFF"/>
@@ -15128,17 +15488,41 @@
                     </a:p>
                   </a:txBody>
                   <a:tcPr anchor="ctr">
-                    <a:lnL>
-                      <a:noFill/>
+                    <a:lnL w="12700" cap="flat" cmpd="sng" algn="ctr">
+                      <a:solidFill>
+                        <a:schemeClr val="tx1"/>
+                      </a:solidFill>
+                      <a:prstDash val="solid"/>
+                      <a:round/>
+                      <a:headEnd type="none" w="med" len="med"/>
+                      <a:tailEnd type="none" w="med" len="med"/>
                     </a:lnL>
-                    <a:lnR>
-                      <a:noFill/>
+                    <a:lnR w="12700" cap="flat" cmpd="sng" algn="ctr">
+                      <a:solidFill>
+                        <a:schemeClr val="tx1"/>
+                      </a:solidFill>
+                      <a:prstDash val="solid"/>
+                      <a:round/>
+                      <a:headEnd type="none" w="med" len="med"/>
+                      <a:tailEnd type="none" w="med" len="med"/>
                     </a:lnR>
-                    <a:lnT>
-                      <a:noFill/>
+                    <a:lnT w="12700" cap="flat" cmpd="sng" algn="ctr">
+                      <a:solidFill>
+                        <a:schemeClr val="tx1"/>
+                      </a:solidFill>
+                      <a:prstDash val="solid"/>
+                      <a:round/>
+                      <a:headEnd type="none" w="med" len="med"/>
+                      <a:tailEnd type="none" w="med" len="med"/>
                     </a:lnT>
-                    <a:lnB>
-                      <a:noFill/>
+                    <a:lnB w="12700" cap="flat" cmpd="sng" algn="ctr">
+                      <a:solidFill>
+                        <a:schemeClr val="tx1"/>
+                      </a:solidFill>
+                      <a:prstDash val="solid"/>
+                      <a:round/>
+                      <a:headEnd type="none" w="med" len="med"/>
+                      <a:tailEnd type="none" w="med" len="med"/>
                     </a:lnB>
                     <a:solidFill>
                       <a:srgbClr val="FFFFFF"/>
@@ -15171,17 +15555,41 @@
                     </a:p>
                   </a:txBody>
                   <a:tcPr anchor="ctr">
-                    <a:lnL>
-                      <a:noFill/>
+                    <a:lnL w="12700" cap="flat" cmpd="sng" algn="ctr">
+                      <a:solidFill>
+                        <a:schemeClr val="tx1"/>
+                      </a:solidFill>
+                      <a:prstDash val="solid"/>
+                      <a:round/>
+                      <a:headEnd type="none" w="med" len="med"/>
+                      <a:tailEnd type="none" w="med" len="med"/>
                     </a:lnL>
-                    <a:lnR>
-                      <a:noFill/>
+                    <a:lnR w="12700" cap="flat" cmpd="sng" algn="ctr">
+                      <a:solidFill>
+                        <a:schemeClr val="tx1"/>
+                      </a:solidFill>
+                      <a:prstDash val="solid"/>
+                      <a:round/>
+                      <a:headEnd type="none" w="med" len="med"/>
+                      <a:tailEnd type="none" w="med" len="med"/>
                     </a:lnR>
-                    <a:lnT>
-                      <a:noFill/>
+                    <a:lnT w="12700" cap="flat" cmpd="sng" algn="ctr">
+                      <a:solidFill>
+                        <a:schemeClr val="tx1"/>
+                      </a:solidFill>
+                      <a:prstDash val="solid"/>
+                      <a:round/>
+                      <a:headEnd type="none" w="med" len="med"/>
+                      <a:tailEnd type="none" w="med" len="med"/>
                     </a:lnT>
-                    <a:lnB>
-                      <a:noFill/>
+                    <a:lnB w="12700" cap="flat" cmpd="sng" algn="ctr">
+                      <a:solidFill>
+                        <a:schemeClr val="tx1"/>
+                      </a:solidFill>
+                      <a:prstDash val="solid"/>
+                      <a:round/>
+                      <a:headEnd type="none" w="med" len="med"/>
+                      <a:tailEnd type="none" w="med" len="med"/>
                     </a:lnB>
                     <a:solidFill>
                       <a:srgbClr val="FFFFFF"/>
@@ -15203,17 +15611,41 @@
                     </a:p>
                   </a:txBody>
                   <a:tcPr anchor="ctr">
-                    <a:lnL>
-                      <a:noFill/>
+                    <a:lnL w="12700" cap="flat" cmpd="sng" algn="ctr">
+                      <a:solidFill>
+                        <a:schemeClr val="tx1"/>
+                      </a:solidFill>
+                      <a:prstDash val="solid"/>
+                      <a:round/>
+                      <a:headEnd type="none" w="med" len="med"/>
+                      <a:tailEnd type="none" w="med" len="med"/>
                     </a:lnL>
-                    <a:lnR>
-                      <a:noFill/>
+                    <a:lnR w="12700" cap="flat" cmpd="sng" algn="ctr">
+                      <a:solidFill>
+                        <a:schemeClr val="tx1"/>
+                      </a:solidFill>
+                      <a:prstDash val="solid"/>
+                      <a:round/>
+                      <a:headEnd type="none" w="med" len="med"/>
+                      <a:tailEnd type="none" w="med" len="med"/>
                     </a:lnR>
-                    <a:lnT>
-                      <a:noFill/>
+                    <a:lnT w="12700" cap="flat" cmpd="sng" algn="ctr">
+                      <a:solidFill>
+                        <a:schemeClr val="tx1"/>
+                      </a:solidFill>
+                      <a:prstDash val="solid"/>
+                      <a:round/>
+                      <a:headEnd type="none" w="med" len="med"/>
+                      <a:tailEnd type="none" w="med" len="med"/>
                     </a:lnT>
-                    <a:lnB>
-                      <a:noFill/>
+                    <a:lnB w="12700" cap="flat" cmpd="sng" algn="ctr">
+                      <a:solidFill>
+                        <a:schemeClr val="tx1"/>
+                      </a:solidFill>
+                      <a:prstDash val="solid"/>
+                      <a:round/>
+                      <a:headEnd type="none" w="med" len="med"/>
+                      <a:tailEnd type="none" w="med" len="med"/>
                     </a:lnB>
                     <a:solidFill>
                       <a:srgbClr val="FFFFFF"/>
@@ -15235,17 +15667,41 @@
                     </a:p>
                   </a:txBody>
                   <a:tcPr anchor="ctr">
-                    <a:lnL>
-                      <a:noFill/>
+                    <a:lnL w="12700" cap="flat" cmpd="sng" algn="ctr">
+                      <a:solidFill>
+                        <a:schemeClr val="tx1"/>
+                      </a:solidFill>
+                      <a:prstDash val="solid"/>
+                      <a:round/>
+                      <a:headEnd type="none" w="med" len="med"/>
+                      <a:tailEnd type="none" w="med" len="med"/>
                     </a:lnL>
-                    <a:lnR>
-                      <a:noFill/>
+                    <a:lnR w="12700" cap="flat" cmpd="sng" algn="ctr">
+                      <a:solidFill>
+                        <a:schemeClr val="tx1"/>
+                      </a:solidFill>
+                      <a:prstDash val="solid"/>
+                      <a:round/>
+                      <a:headEnd type="none" w="med" len="med"/>
+                      <a:tailEnd type="none" w="med" len="med"/>
                     </a:lnR>
-                    <a:lnT>
-                      <a:noFill/>
+                    <a:lnT w="12700" cap="flat" cmpd="sng" algn="ctr">
+                      <a:solidFill>
+                        <a:schemeClr val="tx1"/>
+                      </a:solidFill>
+                      <a:prstDash val="solid"/>
+                      <a:round/>
+                      <a:headEnd type="none" w="med" len="med"/>
+                      <a:tailEnd type="none" w="med" len="med"/>
                     </a:lnT>
-                    <a:lnB>
-                      <a:noFill/>
+                    <a:lnB w="12700" cap="flat" cmpd="sng" algn="ctr">
+                      <a:solidFill>
+                        <a:schemeClr val="tx1"/>
+                      </a:solidFill>
+                      <a:prstDash val="solid"/>
+                      <a:round/>
+                      <a:headEnd type="none" w="med" len="med"/>
+                      <a:tailEnd type="none" w="med" len="med"/>
                     </a:lnB>
                     <a:solidFill>
                       <a:srgbClr val="FFFFFF"/>
@@ -15267,17 +15723,41 @@
                     </a:p>
                   </a:txBody>
                   <a:tcPr anchor="ctr">
-                    <a:lnL>
-                      <a:noFill/>
+                    <a:lnL w="12700" cap="flat" cmpd="sng" algn="ctr">
+                      <a:solidFill>
+                        <a:schemeClr val="tx1"/>
+                      </a:solidFill>
+                      <a:prstDash val="solid"/>
+                      <a:round/>
+                      <a:headEnd type="none" w="med" len="med"/>
+                      <a:tailEnd type="none" w="med" len="med"/>
                     </a:lnL>
-                    <a:lnR>
-                      <a:noFill/>
+                    <a:lnR w="12700" cap="flat" cmpd="sng" algn="ctr">
+                      <a:solidFill>
+                        <a:schemeClr val="tx1"/>
+                      </a:solidFill>
+                      <a:prstDash val="solid"/>
+                      <a:round/>
+                      <a:headEnd type="none" w="med" len="med"/>
+                      <a:tailEnd type="none" w="med" len="med"/>
                     </a:lnR>
-                    <a:lnT>
-                      <a:noFill/>
+                    <a:lnT w="12700" cap="flat" cmpd="sng" algn="ctr">
+                      <a:solidFill>
+                        <a:schemeClr val="tx1"/>
+                      </a:solidFill>
+                      <a:prstDash val="solid"/>
+                      <a:round/>
+                      <a:headEnd type="none" w="med" len="med"/>
+                      <a:tailEnd type="none" w="med" len="med"/>
                     </a:lnT>
-                    <a:lnB>
-                      <a:noFill/>
+                    <a:lnB w="12700" cap="flat" cmpd="sng" algn="ctr">
+                      <a:solidFill>
+                        <a:schemeClr val="tx1"/>
+                      </a:solidFill>
+                      <a:prstDash val="solid"/>
+                      <a:round/>
+                      <a:headEnd type="none" w="med" len="med"/>
+                      <a:tailEnd type="none" w="med" len="med"/>
                     </a:lnB>
                     <a:solidFill>
                       <a:srgbClr val="FFFFFF"/>
@@ -15303,17 +15783,41 @@
                     </a:p>
                   </a:txBody>
                   <a:tcPr anchor="ctr">
-                    <a:lnL>
-                      <a:noFill/>
+                    <a:lnL w="12700" cap="flat" cmpd="sng" algn="ctr">
+                      <a:solidFill>
+                        <a:schemeClr val="tx1"/>
+                      </a:solidFill>
+                      <a:prstDash val="solid"/>
+                      <a:round/>
+                      <a:headEnd type="none" w="med" len="med"/>
+                      <a:tailEnd type="none" w="med" len="med"/>
                     </a:lnL>
-                    <a:lnR>
-                      <a:noFill/>
+                    <a:lnR w="12700" cap="flat" cmpd="sng" algn="ctr">
+                      <a:solidFill>
+                        <a:schemeClr val="tx1"/>
+                      </a:solidFill>
+                      <a:prstDash val="solid"/>
+                      <a:round/>
+                      <a:headEnd type="none" w="med" len="med"/>
+                      <a:tailEnd type="none" w="med" len="med"/>
                     </a:lnR>
-                    <a:lnT>
-                      <a:noFill/>
+                    <a:lnT w="12700" cap="flat" cmpd="sng" algn="ctr">
+                      <a:solidFill>
+                        <a:schemeClr val="tx1"/>
+                      </a:solidFill>
+                      <a:prstDash val="solid"/>
+                      <a:round/>
+                      <a:headEnd type="none" w="med" len="med"/>
+                      <a:tailEnd type="none" w="med" len="med"/>
                     </a:lnT>
-                    <a:lnB>
-                      <a:noFill/>
+                    <a:lnB w="12700" cap="flat" cmpd="sng" algn="ctr">
+                      <a:solidFill>
+                        <a:schemeClr val="tx1"/>
+                      </a:solidFill>
+                      <a:prstDash val="solid"/>
+                      <a:round/>
+                      <a:headEnd type="none" w="med" len="med"/>
+                      <a:tailEnd type="none" w="med" len="med"/>
                     </a:lnB>
                     <a:solidFill>
                       <a:srgbClr val="FFFFFF"/>
@@ -15332,17 +15836,41 @@
                     </a:p>
                   </a:txBody>
                   <a:tcPr anchor="ctr">
-                    <a:lnL>
-                      <a:noFill/>
+                    <a:lnL w="12700" cap="flat" cmpd="sng" algn="ctr">
+                      <a:solidFill>
+                        <a:schemeClr val="tx1"/>
+                      </a:solidFill>
+                      <a:prstDash val="solid"/>
+                      <a:round/>
+                      <a:headEnd type="none" w="med" len="med"/>
+                      <a:tailEnd type="none" w="med" len="med"/>
                     </a:lnL>
-                    <a:lnR>
-                      <a:noFill/>
+                    <a:lnR w="12700" cap="flat" cmpd="sng" algn="ctr">
+                      <a:solidFill>
+                        <a:schemeClr val="tx1"/>
+                      </a:solidFill>
+                      <a:prstDash val="solid"/>
+                      <a:round/>
+                      <a:headEnd type="none" w="med" len="med"/>
+                      <a:tailEnd type="none" w="med" len="med"/>
                     </a:lnR>
-                    <a:lnT>
-                      <a:noFill/>
+                    <a:lnT w="12700" cap="flat" cmpd="sng" algn="ctr">
+                      <a:solidFill>
+                        <a:schemeClr val="tx1"/>
+                      </a:solidFill>
+                      <a:prstDash val="solid"/>
+                      <a:round/>
+                      <a:headEnd type="none" w="med" len="med"/>
+                      <a:tailEnd type="none" w="med" len="med"/>
                     </a:lnT>
-                    <a:lnB>
-                      <a:noFill/>
+                    <a:lnB w="12700" cap="flat" cmpd="sng" algn="ctr">
+                      <a:solidFill>
+                        <a:schemeClr val="tx1"/>
+                      </a:solidFill>
+                      <a:prstDash val="solid"/>
+                      <a:round/>
+                      <a:headEnd type="none" w="med" len="med"/>
+                      <a:tailEnd type="none" w="med" len="med"/>
                     </a:lnB>
                     <a:solidFill>
                       <a:srgbClr val="FFFFFF"/>
@@ -15361,17 +15889,41 @@
                     </a:p>
                   </a:txBody>
                   <a:tcPr anchor="ctr">
-                    <a:lnL>
-                      <a:noFill/>
+                    <a:lnL w="12700" cap="flat" cmpd="sng" algn="ctr">
+                      <a:solidFill>
+                        <a:schemeClr val="tx1"/>
+                      </a:solidFill>
+                      <a:prstDash val="solid"/>
+                      <a:round/>
+                      <a:headEnd type="none" w="med" len="med"/>
+                      <a:tailEnd type="none" w="med" len="med"/>
                     </a:lnL>
-                    <a:lnR>
-                      <a:noFill/>
+                    <a:lnR w="12700" cap="flat" cmpd="sng" algn="ctr">
+                      <a:solidFill>
+                        <a:schemeClr val="tx1"/>
+                      </a:solidFill>
+                      <a:prstDash val="solid"/>
+                      <a:round/>
+                      <a:headEnd type="none" w="med" len="med"/>
+                      <a:tailEnd type="none" w="med" len="med"/>
                     </a:lnR>
-                    <a:lnT>
-                      <a:noFill/>
+                    <a:lnT w="12700" cap="flat" cmpd="sng" algn="ctr">
+                      <a:solidFill>
+                        <a:schemeClr val="tx1"/>
+                      </a:solidFill>
+                      <a:prstDash val="solid"/>
+                      <a:round/>
+                      <a:headEnd type="none" w="med" len="med"/>
+                      <a:tailEnd type="none" w="med" len="med"/>
                     </a:lnT>
-                    <a:lnB>
-                      <a:noFill/>
+                    <a:lnB w="12700" cap="flat" cmpd="sng" algn="ctr">
+                      <a:solidFill>
+                        <a:schemeClr val="tx1"/>
+                      </a:solidFill>
+                      <a:prstDash val="solid"/>
+                      <a:round/>
+                      <a:headEnd type="none" w="med" len="med"/>
+                      <a:tailEnd type="none" w="med" len="med"/>
                     </a:lnB>
                     <a:solidFill>
                       <a:srgbClr val="FFFFFF"/>
@@ -15390,17 +15942,41 @@
                     </a:p>
                   </a:txBody>
                   <a:tcPr anchor="ctr">
-                    <a:lnL>
-                      <a:noFill/>
+                    <a:lnL w="12700" cap="flat" cmpd="sng" algn="ctr">
+                      <a:solidFill>
+                        <a:schemeClr val="tx1"/>
+                      </a:solidFill>
+                      <a:prstDash val="solid"/>
+                      <a:round/>
+                      <a:headEnd type="none" w="med" len="med"/>
+                      <a:tailEnd type="none" w="med" len="med"/>
                     </a:lnL>
-                    <a:lnR>
-                      <a:noFill/>
+                    <a:lnR w="12700" cap="flat" cmpd="sng" algn="ctr">
+                      <a:solidFill>
+                        <a:schemeClr val="tx1"/>
+                      </a:solidFill>
+                      <a:prstDash val="solid"/>
+                      <a:round/>
+                      <a:headEnd type="none" w="med" len="med"/>
+                      <a:tailEnd type="none" w="med" len="med"/>
                     </a:lnR>
-                    <a:lnT>
-                      <a:noFill/>
+                    <a:lnT w="12700" cap="flat" cmpd="sng" algn="ctr">
+                      <a:solidFill>
+                        <a:schemeClr val="tx1"/>
+                      </a:solidFill>
+                      <a:prstDash val="solid"/>
+                      <a:round/>
+                      <a:headEnd type="none" w="med" len="med"/>
+                      <a:tailEnd type="none" w="med" len="med"/>
                     </a:lnT>
-                    <a:lnB>
-                      <a:noFill/>
+                    <a:lnB w="12700" cap="flat" cmpd="sng" algn="ctr">
+                      <a:solidFill>
+                        <a:schemeClr val="tx1"/>
+                      </a:solidFill>
+                      <a:prstDash val="solid"/>
+                      <a:round/>
+                      <a:headEnd type="none" w="med" len="med"/>
+                      <a:tailEnd type="none" w="med" len="med"/>
                     </a:lnB>
                     <a:solidFill>
                       <a:srgbClr val="FFFFFF"/>
@@ -15430,17 +16006,41 @@
                     </a:p>
                   </a:txBody>
                   <a:tcPr anchor="ctr">
-                    <a:lnL>
-                      <a:noFill/>
+                    <a:lnL w="12700" cap="flat" cmpd="sng" algn="ctr">
+                      <a:solidFill>
+                        <a:schemeClr val="tx1"/>
+                      </a:solidFill>
+                      <a:prstDash val="solid"/>
+                      <a:round/>
+                      <a:headEnd type="none" w="med" len="med"/>
+                      <a:tailEnd type="none" w="med" len="med"/>
                     </a:lnL>
-                    <a:lnR>
-                      <a:noFill/>
+                    <a:lnR w="12700" cap="flat" cmpd="sng" algn="ctr">
+                      <a:solidFill>
+                        <a:schemeClr val="tx1"/>
+                      </a:solidFill>
+                      <a:prstDash val="solid"/>
+                      <a:round/>
+                      <a:headEnd type="none" w="med" len="med"/>
+                      <a:tailEnd type="none" w="med" len="med"/>
                     </a:lnR>
-                    <a:lnT>
-                      <a:noFill/>
+                    <a:lnT w="12700" cap="flat" cmpd="sng" algn="ctr">
+                      <a:solidFill>
+                        <a:schemeClr val="tx1"/>
+                      </a:solidFill>
+                      <a:prstDash val="solid"/>
+                      <a:round/>
+                      <a:headEnd type="none" w="med" len="med"/>
+                      <a:tailEnd type="none" w="med" len="med"/>
                     </a:lnT>
-                    <a:lnB>
-                      <a:noFill/>
+                    <a:lnB w="12700" cap="flat" cmpd="sng" algn="ctr">
+                      <a:solidFill>
+                        <a:schemeClr val="tx1"/>
+                      </a:solidFill>
+                      <a:prstDash val="solid"/>
+                      <a:round/>
+                      <a:headEnd type="none" w="med" len="med"/>
+                      <a:tailEnd type="none" w="med" len="med"/>
                     </a:lnB>
                     <a:solidFill>
                       <a:srgbClr val="FFFFFF"/>
@@ -15462,17 +16062,41 @@
                     </a:p>
                   </a:txBody>
                   <a:tcPr anchor="ctr">
-                    <a:lnL>
-                      <a:noFill/>
+                    <a:lnL w="12700" cap="flat" cmpd="sng" algn="ctr">
+                      <a:solidFill>
+                        <a:schemeClr val="tx1"/>
+                      </a:solidFill>
+                      <a:prstDash val="solid"/>
+                      <a:round/>
+                      <a:headEnd type="none" w="med" len="med"/>
+                      <a:tailEnd type="none" w="med" len="med"/>
                     </a:lnL>
-                    <a:lnR>
-                      <a:noFill/>
+                    <a:lnR w="12700" cap="flat" cmpd="sng" algn="ctr">
+                      <a:solidFill>
+                        <a:schemeClr val="tx1"/>
+                      </a:solidFill>
+                      <a:prstDash val="solid"/>
+                      <a:round/>
+                      <a:headEnd type="none" w="med" len="med"/>
+                      <a:tailEnd type="none" w="med" len="med"/>
                     </a:lnR>
-                    <a:lnT>
-                      <a:noFill/>
+                    <a:lnT w="12700" cap="flat" cmpd="sng" algn="ctr">
+                      <a:solidFill>
+                        <a:schemeClr val="tx1"/>
+                      </a:solidFill>
+                      <a:prstDash val="solid"/>
+                      <a:round/>
+                      <a:headEnd type="none" w="med" len="med"/>
+                      <a:tailEnd type="none" w="med" len="med"/>
                     </a:lnT>
-                    <a:lnB>
-                      <a:noFill/>
+                    <a:lnB w="12700" cap="flat" cmpd="sng" algn="ctr">
+                      <a:solidFill>
+                        <a:schemeClr val="tx1"/>
+                      </a:solidFill>
+                      <a:prstDash val="solid"/>
+                      <a:round/>
+                      <a:headEnd type="none" w="med" len="med"/>
+                      <a:tailEnd type="none" w="med" len="med"/>
                     </a:lnB>
                     <a:solidFill>
                       <a:srgbClr val="FFFFFF"/>
@@ -15494,17 +16118,41 @@
                     </a:p>
                   </a:txBody>
                   <a:tcPr anchor="ctr">
-                    <a:lnL>
-                      <a:noFill/>
+                    <a:lnL w="12700" cap="flat" cmpd="sng" algn="ctr">
+                      <a:solidFill>
+                        <a:schemeClr val="tx1"/>
+                      </a:solidFill>
+                      <a:prstDash val="solid"/>
+                      <a:round/>
+                      <a:headEnd type="none" w="med" len="med"/>
+                      <a:tailEnd type="none" w="med" len="med"/>
                     </a:lnL>
-                    <a:lnR>
-                      <a:noFill/>
+                    <a:lnR w="12700" cap="flat" cmpd="sng" algn="ctr">
+                      <a:solidFill>
+                        <a:schemeClr val="tx1"/>
+                      </a:solidFill>
+                      <a:prstDash val="solid"/>
+                      <a:round/>
+                      <a:headEnd type="none" w="med" len="med"/>
+                      <a:tailEnd type="none" w="med" len="med"/>
                     </a:lnR>
-                    <a:lnT>
-                      <a:noFill/>
+                    <a:lnT w="12700" cap="flat" cmpd="sng" algn="ctr">
+                      <a:solidFill>
+                        <a:schemeClr val="tx1"/>
+                      </a:solidFill>
+                      <a:prstDash val="solid"/>
+                      <a:round/>
+                      <a:headEnd type="none" w="med" len="med"/>
+                      <a:tailEnd type="none" w="med" len="med"/>
                     </a:lnT>
-                    <a:lnB>
-                      <a:noFill/>
+                    <a:lnB w="12700" cap="flat" cmpd="sng" algn="ctr">
+                      <a:solidFill>
+                        <a:schemeClr val="tx1"/>
+                      </a:solidFill>
+                      <a:prstDash val="solid"/>
+                      <a:round/>
+                      <a:headEnd type="none" w="med" len="med"/>
+                      <a:tailEnd type="none" w="med" len="med"/>
                     </a:lnB>
                     <a:solidFill>
                       <a:srgbClr val="FFFFFF"/>
@@ -15526,17 +16174,41 @@
                     </a:p>
                   </a:txBody>
                   <a:tcPr anchor="ctr">
-                    <a:lnL>
-                      <a:noFill/>
+                    <a:lnL w="12700" cap="flat" cmpd="sng" algn="ctr">
+                      <a:solidFill>
+                        <a:schemeClr val="tx1"/>
+                      </a:solidFill>
+                      <a:prstDash val="solid"/>
+                      <a:round/>
+                      <a:headEnd type="none" w="med" len="med"/>
+                      <a:tailEnd type="none" w="med" len="med"/>
                     </a:lnL>
-                    <a:lnR>
-                      <a:noFill/>
+                    <a:lnR w="12700" cap="flat" cmpd="sng" algn="ctr">
+                      <a:solidFill>
+                        <a:schemeClr val="tx1"/>
+                      </a:solidFill>
+                      <a:prstDash val="solid"/>
+                      <a:round/>
+                      <a:headEnd type="none" w="med" len="med"/>
+                      <a:tailEnd type="none" w="med" len="med"/>
                     </a:lnR>
-                    <a:lnT>
-                      <a:noFill/>
+                    <a:lnT w="12700" cap="flat" cmpd="sng" algn="ctr">
+                      <a:solidFill>
+                        <a:schemeClr val="tx1"/>
+                      </a:solidFill>
+                      <a:prstDash val="solid"/>
+                      <a:round/>
+                      <a:headEnd type="none" w="med" len="med"/>
+                      <a:tailEnd type="none" w="med" len="med"/>
                     </a:lnT>
-                    <a:lnB>
-                      <a:noFill/>
+                    <a:lnB w="12700" cap="flat" cmpd="sng" algn="ctr">
+                      <a:solidFill>
+                        <a:schemeClr val="tx1"/>
+                      </a:solidFill>
+                      <a:prstDash val="solid"/>
+                      <a:round/>
+                      <a:headEnd type="none" w="med" len="med"/>
+                      <a:tailEnd type="none" w="med" len="med"/>
                     </a:lnB>
                     <a:solidFill>
                       <a:srgbClr val="FFFFFF"/>

</xml_diff>